<commit_message>
Capstone deck: starry sky
Co-Authored-By: Claude Opus 5.5 <noreply@anthropic.com>
Claude-Session: https://claude.ai/code/session_01ScysB3hpFWQZ6JoQjpf1xs
</commit_message>
<xml_diff>
--- a/downloads/slides/FYE100-STARTStories-Overview-Slides.pptx
+++ b/downloads/slides/FYE100-STARTStories-Overview-Slides.pptx
@@ -119,17 +119,17 @@
   <p:extLst>
     <p:ext uri="{521415D9-36F7-43E2-AB2F-B90AF26B5E84}">
       <p14:sectionLst xmlns:p14="http://schemas.microsoft.com/office/powerpoint/2010/main">
-        <p14:section name="Opening" id="{341ccca8-0d9f-1740-2537-0398d59ffe18}">
+        <p14:section name="Opening" id="{964ceb15-ab28-b7ea-107b-9012b3cc0787}">
           <p14:sldIdLst>
             <p14:sldId id="256"/>
           </p14:sldIdLst>
         </p14:section>
-        <p14:section name="This week" id="{508d6826-6a72-2434-7515-b8d29c344f0e}">
+        <p14:section name="This week" id="{17d9c13b-90d4-bf20-04ff-cd24351c25c8}">
           <p14:sldIdLst>
             <p14:sldId id="257"/>
           </p14:sldIdLst>
         </p14:section>
-        <p14:section name="Lessons" id="{88608d83-a9ab-e0c7-6b09-a71c0de38b87}">
+        <p14:section name="Lessons" id="{ddc930b5-c7e7-f0ce-50b9-d6d168dbcf26}">
           <p14:sldIdLst>
             <p14:sldId id="258"/>
             <p14:sldId id="259"/>
@@ -142,12 +142,12 @@
             <p14:sldId id="266"/>
           </p14:sldIdLst>
         </p14:section>
-        <p14:section name="This week's work" id="{d75f01fa-f11f-30f4-0eab-c0b67d1fea3f}">
+        <p14:section name="This week's work" id="{923d0e99-402d-81ef-4a18-b4bf820dd270}">
           <p14:sldIdLst>
             <p14:sldId id="267"/>
           </p14:sldIdLst>
         </p14:section>
-        <p14:section name="Discussion" id="{650149ca-4963-069a-da38-f73e8343f3b4}">
+        <p14:section name="Discussion" id="{e779d9db-f633-3917-def7-e07deafad403}">
           <p14:sldIdLst>
             <p14:sldId id="268"/>
           </p14:sldIdLst>

</xml_diff>

<commit_message>
Capstone deck: owl waves a checkered start flag
Co-Authored-By: Claude Opus 5.5 <noreply@anthropic.com>
Claude-Session: https://claude.ai/code/session_01ScysB3hpFWQZ6JoQjpf1xs
</commit_message>
<xml_diff>
--- a/downloads/slides/FYE100-STARTStories-Overview-Slides.pptx
+++ b/downloads/slides/FYE100-STARTStories-Overview-Slides.pptx
@@ -119,17 +119,17 @@
   <p:extLst>
     <p:ext uri="{521415D9-36F7-43E2-AB2F-B90AF26B5E84}">
       <p14:sectionLst xmlns:p14="http://schemas.microsoft.com/office/powerpoint/2010/main">
-        <p14:section name="Opening" id="{964ceb15-ab28-b7ea-107b-9012b3cc0787}">
+        <p14:section name="Opening" id="{7a2ae232-cf4e-274b-2b10-4a14a358e118}">
           <p14:sldIdLst>
             <p14:sldId id="256"/>
           </p14:sldIdLst>
         </p14:section>
-        <p14:section name="This week" id="{17d9c13b-90d4-bf20-04ff-cd24351c25c8}">
+        <p14:section name="This week" id="{1ed3a618-7c50-3a1d-d374-1c16a8fa6c4b}">
           <p14:sldIdLst>
             <p14:sldId id="257"/>
           </p14:sldIdLst>
         </p14:section>
-        <p14:section name="Lessons" id="{ddc930b5-c7e7-f0ce-50b9-d6d168dbcf26}">
+        <p14:section name="Lessons" id="{f32ce936-1892-16b7-e499-8847997fba98}">
           <p14:sldIdLst>
             <p14:sldId id="258"/>
             <p14:sldId id="259"/>
@@ -142,12 +142,12 @@
             <p14:sldId id="266"/>
           </p14:sldIdLst>
         </p14:section>
-        <p14:section name="This week's work" id="{923d0e99-402d-81ef-4a18-b4bf820dd270}">
+        <p14:section name="This week's work" id="{4999320c-5937-b23b-8ed7-3187b69db48c}">
           <p14:sldIdLst>
             <p14:sldId id="267"/>
           </p14:sldIdLst>
         </p14:section>
-        <p14:section name="Discussion" id="{e779d9db-f633-3917-def7-e07deafad403}">
+        <p14:section name="Discussion" id="{d1ef5ce1-58e2-62c2-a3d8-9cbbe1671b0c}">
           <p14:sldIdLst>
             <p14:sldId id="268"/>
           </p14:sldIdLst>
@@ -558,7 +558,7 @@
               <a:rPr lang="en-US" dirty="0"/>
               <a:t>Welcome to the capstone: STAR(T) Stories.
 Anyone can claim a skill. Your stories show it. This deck walks through the framework, how to pick your stories, how to tell them, and how to make them strong.
-The owl has a microphone this time. It's ready to tell its story, and by the end of the semester, so are you.</a:t>
+The owl is waving the start flag this time. Your stories are the finish line of the course, and the starting line for every interview after it.</a:t>
             </a:r>
             <a:endParaRPr lang="en-US" dirty="0"/>
           </a:p>

</xml_diff>